<commit_message>
Update pitch deck with new slide on Solana's advantages for agent micropayments and adjust footers for consistency across slides. Increment slide numbers to reflect the addition of the new content.
</commit_message>
<xml_diff>
--- a/docs/pitch/hackathon-deck.pptx
+++ b/docs/pitch/hackathon-deck.pptx
@@ -12,6 +12,7 @@
     <p:sldId id="260" r:id="rId12"/>
     <p:sldId id="261" r:id="rId13"/>
     <p:sldId id="262" r:id="rId14"/>
+    <p:sldId id="263" r:id="rId15"/>
   </p:sldIdLst>
   <p:sldSz cx="12191695" cy="6858000" type="screen4x3"/>
   <p:notesSz cx="6858000" cy="9144000"/>
@@ -884,6 +885,76 @@
 </file>
 
 <file path=ppt/notesSlides/notesSlide7.xml><?xml version="1.0" encoding="utf-8"?>
+<p:notes xmlns:a="http://schemas.openxmlformats.org/drawingml/2006/main" xmlns:p="http://schemas.openxmlformats.org/presentationml/2006/main" xmlns:r="http://schemas.openxmlformats.org/officeDocument/2006/relationships">
+  <p:cSld>
+    <p:spTree>
+      <p:nvGrpSpPr>
+        <p:cNvPr id="1" name=""/>
+        <p:cNvGrpSpPr/>
+        <p:nvPr/>
+      </p:nvGrpSpPr>
+      <p:grpSpPr>
+        <a:xfrm>
+          <a:off x="0" y="0"/>
+          <a:ext cx="0" cy="0"/>
+          <a:chOff x="0" y="0"/>
+          <a:chExt cx="0" cy="0"/>
+        </a:xfrm>
+      </p:grpSpPr>
+      <p:sp>
+        <p:nvSpPr>
+          <p:cNvPr id="2" name="Slide Image Placeholder 1"/>
+          <p:cNvSpPr>
+            <a:spLocks noGrp="1"/>
+          </p:cNvSpPr>
+          <p:nvPr>
+            <p:ph type="sldImg" idx="2"/>
+          </p:nvPr>
+        </p:nvSpPr>
+        <p:spPr/>
+      </p:sp>
+      <p:sp>
+        <p:nvSpPr>
+          <p:cNvPr id="3" name="Notes Placeholder 2"/>
+          <p:cNvSpPr>
+            <a:spLocks noGrp="1"/>
+          </p:cNvSpPr>
+          <p:nvPr>
+            <p:ph type="body" idx="3" sz="quarter"/>
+          </p:nvPr>
+        </p:nvSpPr>
+        <p:spPr/>
+        <p:txBody>
+          <a:bodyPr/>
+          <a:lstStyle/>
+          <a:p>
+            <a:r>
+              <a:t>This isn't a 'we chose Solana because it's fast' slide. The transferFixed instruction from @solana/subscriptions is the specific primitive SAFE is built on — it lets an agent spend from a pre-authorized allowance pool rather than a fully open wallet. No other chain has an equivalent native subscription/allowance model at this maturity. The sub-cent fees and sub-second finality make per-payment policy checks practical at scale.</a:t>
+            </a:r>
+          </a:p>
+        </p:txBody>
+      </p:sp>
+      <p:sp>
+        <p:nvSpPr>
+          <p:cNvPr id="4" name="Slide Number Placeholder 3"/>
+          <p:cNvSpPr>
+            <a:spLocks noGrp="1"/>
+          </p:cNvSpPr>
+          <p:nvPr>
+            <p:ph type="sldNum" idx="5" sz="quarter"/>
+          </p:nvPr>
+        </p:nvSpPr>
+        <p:spPr/>
+      </p:sp>
+    </p:spTree>
+  </p:cSld>
+  <p:clrMapOvr>
+    <a:masterClrMapping/>
+  </p:clrMapOvr>
+</p:notes>
+</file>
+
+<file path=ppt/notesSlides/notesSlide8.xml><?xml version="1.0" encoding="utf-8"?>
 <p:notes xmlns:a="http://schemas.openxmlformats.org/drawingml/2006/main" xmlns:p="http://schemas.openxmlformats.org/presentationml/2006/main" xmlns:r="http://schemas.openxmlformats.org/officeDocument/2006/relationships">
   <p:cSld>
     <p:spTree>
@@ -4417,7 +4488,7 @@
                 </a:solidFill>
                 <a:latin typeface="Calibri"/>
               </a:rPr>
-              <a:t>01 / 07</a:t>
+              <a:t>01 / 08</a:t>
             </a:r>
           </a:p>
         </p:txBody>
@@ -5245,7 +5316,7 @@
                 </a:solidFill>
                 <a:latin typeface="Calibri"/>
               </a:rPr>
-              <a:t>02 / 07</a:t>
+              <a:t>02 / 08</a:t>
             </a:r>
           </a:p>
         </p:txBody>
@@ -6186,7 +6257,7 @@
                 </a:solidFill>
                 <a:latin typeface="Calibri"/>
               </a:rPr>
-              <a:t>03 / 07</a:t>
+              <a:t>03 / 08</a:t>
             </a:r>
           </a:p>
         </p:txBody>
@@ -6852,7 +6923,7 @@
                 </a:solidFill>
                 <a:latin typeface="Calibri"/>
               </a:rPr>
-              <a:t>04 / 07</a:t>
+              <a:t>04 / 08</a:t>
             </a:r>
           </a:p>
         </p:txBody>
@@ -7826,7 +7897,7 @@
                 </a:solidFill>
                 <a:latin typeface="Calibri"/>
               </a:rPr>
-              <a:t>05 / 07</a:t>
+              <a:t>05 / 08</a:t>
             </a:r>
           </a:p>
         </p:txBody>
@@ -8776,7 +8847,7 @@
                 </a:solidFill>
                 <a:latin typeface="Calibri"/>
               </a:rPr>
-              <a:t>06 / 07</a:t>
+              <a:t>06 / 08</a:t>
             </a:r>
           </a:p>
         </p:txBody>
@@ -8837,7 +8908,7 @@
                 </a:solidFill>
                 <a:latin typeface="Courier New"/>
               </a:rPr>
-              <a:t>// Grand Vision</a:t>
+              <a:t>// Why Solana?</a:t>
             </a:r>
           </a:p>
         </p:txBody>
@@ -8872,7 +8943,7 @@
                 </a:solidFill>
                 <a:latin typeface="Calibri"/>
               </a:rPr>
-              <a:t>Private-first, shared-by-proof</a:t>
+              <a:t>The only chain with a native agent-payment primitive.</a:t>
             </a:r>
           </a:p>
         </p:txBody>
@@ -8886,7 +8957,7 @@
         <p:spPr>
           <a:xfrm>
             <a:off x="640080" y="1005840"/>
-            <a:ext cx="5943600" cy="822960"/>
+            <a:ext cx="10515600" cy="822960"/>
           </a:xfrm>
           <a:prstGeom prst="rect">
             <a:avLst/>
@@ -8907,7 +8978,7 @@
                 </a:solidFill>
                 <a:latin typeface="Calibri"/>
               </a:rPr>
-              <a:t>From payment firewall to shared trust layer.</a:t>
+              <a:t>Solana is purpose-built for agent micropayments.</a:t>
             </a:r>
           </a:p>
         </p:txBody>
@@ -8921,7 +8992,7 @@
         <p:spPr>
           <a:xfrm>
             <a:off x="640080" y="1920240"/>
-            <a:ext cx="5669280" cy="822960"/>
+            <a:ext cx="10515600" cy="594360"/>
           </a:xfrm>
           <a:prstGeom prst="rect">
             <a:avLst/>
@@ -8942,7 +9013,7 @@
                 </a:solidFill>
                 <a:latin typeface="Calibri"/>
               </a:rPr>
-              <a:t>SAFE starts local. Then unknown payments can be verified by private agents, turned into signed evidence, and reused as sanitized trust signals.</a:t>
+              <a:t>Every design choice in SAFE — allowances, transferFixed, sub-cent fees, sub-second finality — is possible because of how Solana works.</a:t>
             </a:r>
           </a:p>
         </p:txBody>
@@ -8955,8 +9026,452 @@
         </p:nvSpPr>
         <p:spPr>
           <a:xfrm>
-            <a:off x="640080" y="2926080"/>
-            <a:ext cx="1984248" cy="256032"/>
+            <a:off x="640080" y="2743200"/>
+            <a:ext cx="3566160" cy="1417320"/>
+          </a:xfrm>
+          <a:prstGeom prst="rect">
+            <a:avLst/>
+          </a:prstGeom>
+          <a:solidFill>
+            <a:srgbClr val="14171F"/>
+          </a:solidFill>
+          <a:ln>
+            <a:noFill/>
+          </a:ln>
+        </p:spPr>
+        <p:style>
+          <a:lnRef idx="1">
+            <a:schemeClr val="accent1"/>
+          </a:lnRef>
+          <a:fillRef idx="3">
+            <a:schemeClr val="accent1"/>
+          </a:fillRef>
+          <a:effectRef idx="2">
+            <a:schemeClr val="accent1"/>
+          </a:effectRef>
+          <a:fontRef idx="minor">
+            <a:schemeClr val="lt1"/>
+          </a:fontRef>
+        </p:style>
+        <p:txBody>
+          <a:bodyPr rtlCol="0" anchor="ctr"/>
+          <a:lstStyle/>
+          <a:p>
+            <a:pPr algn="ctr"/>
+          </a:p>
+        </p:txBody>
+      </p:sp>
+      <p:sp>
+        <p:nvSpPr>
+          <p:cNvPr id="7" name="TextBox 6"/>
+          <p:cNvSpPr txBox="1"/>
+          <p:nvPr/>
+        </p:nvSpPr>
+        <p:spPr>
+          <a:xfrm>
+            <a:off x="804672" y="2834640"/>
+            <a:ext cx="3337560" cy="457200"/>
+          </a:xfrm>
+          <a:prstGeom prst="rect">
+            <a:avLst/>
+          </a:prstGeom>
+          <a:noFill/>
+        </p:spPr>
+        <p:txBody>
+          <a:bodyPr wrap="square">
+            <a:spAutoFit/>
+          </a:bodyPr>
+          <a:lstStyle/>
+          <a:p>
+            <a:pPr algn="l"/>
+            <a:r>
+              <a:rPr b="1" i="0" sz="2200">
+                <a:solidFill>
+                  <a:srgbClr val="14F195"/>
+                </a:solidFill>
+                <a:latin typeface="Calibri"/>
+              </a:rPr>
+              <a:t>~$0.00025</a:t>
+            </a:r>
+          </a:p>
+        </p:txBody>
+      </p:sp>
+      <p:sp>
+        <p:nvSpPr>
+          <p:cNvPr id="8" name="TextBox 7"/>
+          <p:cNvSpPr txBox="1"/>
+          <p:nvPr/>
+        </p:nvSpPr>
+        <p:spPr>
+          <a:xfrm>
+            <a:off x="804672" y="3273552"/>
+            <a:ext cx="3337560" cy="256032"/>
+          </a:xfrm>
+          <a:prstGeom prst="rect">
+            <a:avLst/>
+          </a:prstGeom>
+          <a:noFill/>
+        </p:spPr>
+        <p:txBody>
+          <a:bodyPr wrap="square">
+            <a:spAutoFit/>
+          </a:bodyPr>
+          <a:lstStyle/>
+          <a:p>
+            <a:pPr algn="l"/>
+            <a:r>
+              <a:rPr b="1" i="0" sz="1100">
+                <a:solidFill>
+                  <a:srgbClr val="A2A8B4"/>
+                </a:solidFill>
+                <a:latin typeface="Calibri"/>
+              </a:rPr>
+              <a:t>per transaction</a:t>
+            </a:r>
+          </a:p>
+        </p:txBody>
+      </p:sp>
+      <p:sp>
+        <p:nvSpPr>
+          <p:cNvPr id="9" name="TextBox 8"/>
+          <p:cNvSpPr txBox="1"/>
+          <p:nvPr/>
+        </p:nvSpPr>
+        <p:spPr>
+          <a:xfrm>
+            <a:off x="804672" y="3566160"/>
+            <a:ext cx="3337560" cy="502920"/>
+          </a:xfrm>
+          <a:prstGeom prst="rect">
+            <a:avLst/>
+          </a:prstGeom>
+          <a:noFill/>
+        </p:spPr>
+        <p:txBody>
+          <a:bodyPr wrap="square">
+            <a:spAutoFit/>
+          </a:bodyPr>
+          <a:lstStyle/>
+          <a:p>
+            <a:pPr algn="l"/>
+            <a:r>
+              <a:rPr b="0" i="0" sz="1000">
+                <a:solidFill>
+                  <a:srgbClr val="6B7280"/>
+                </a:solidFill>
+                <a:latin typeface="Calibri"/>
+              </a:rPr>
+              <a:t>Sub-cent fees make micropayment firewalls economically viable.</a:t>
+            </a:r>
+          </a:p>
+        </p:txBody>
+      </p:sp>
+      <p:sp>
+        <p:nvSpPr>
+          <p:cNvPr id="10" name="Rectangle 9"/>
+          <p:cNvSpPr/>
+          <p:nvPr/>
+        </p:nvSpPr>
+        <p:spPr>
+          <a:xfrm>
+            <a:off x="4343400" y="2743200"/>
+            <a:ext cx="3566160" cy="1417320"/>
+          </a:xfrm>
+          <a:prstGeom prst="rect">
+            <a:avLst/>
+          </a:prstGeom>
+          <a:solidFill>
+            <a:srgbClr val="14171F"/>
+          </a:solidFill>
+          <a:ln>
+            <a:noFill/>
+          </a:ln>
+        </p:spPr>
+        <p:style>
+          <a:lnRef idx="1">
+            <a:schemeClr val="accent1"/>
+          </a:lnRef>
+          <a:fillRef idx="3">
+            <a:schemeClr val="accent1"/>
+          </a:fillRef>
+          <a:effectRef idx="2">
+            <a:schemeClr val="accent1"/>
+          </a:effectRef>
+          <a:fontRef idx="minor">
+            <a:schemeClr val="lt1"/>
+          </a:fontRef>
+        </p:style>
+        <p:txBody>
+          <a:bodyPr rtlCol="0" anchor="ctr"/>
+          <a:lstStyle/>
+          <a:p>
+            <a:pPr algn="ctr"/>
+          </a:p>
+        </p:txBody>
+      </p:sp>
+      <p:sp>
+        <p:nvSpPr>
+          <p:cNvPr id="11" name="TextBox 10"/>
+          <p:cNvSpPr txBox="1"/>
+          <p:nvPr/>
+        </p:nvSpPr>
+        <p:spPr>
+          <a:xfrm>
+            <a:off x="4507992" y="2834640"/>
+            <a:ext cx="3337560" cy="457200"/>
+          </a:xfrm>
+          <a:prstGeom prst="rect">
+            <a:avLst/>
+          </a:prstGeom>
+          <a:noFill/>
+        </p:spPr>
+        <p:txBody>
+          <a:bodyPr wrap="square">
+            <a:spAutoFit/>
+          </a:bodyPr>
+          <a:lstStyle/>
+          <a:p>
+            <a:pPr algn="l"/>
+            <a:r>
+              <a:rPr b="1" i="0" sz="2200">
+                <a:solidFill>
+                  <a:srgbClr val="F4F7FA"/>
+                </a:solidFill>
+                <a:latin typeface="Calibri"/>
+              </a:rPr>
+              <a:t>&lt;400 ms</a:t>
+            </a:r>
+          </a:p>
+        </p:txBody>
+      </p:sp>
+      <p:sp>
+        <p:nvSpPr>
+          <p:cNvPr id="12" name="TextBox 11"/>
+          <p:cNvSpPr txBox="1"/>
+          <p:nvPr/>
+        </p:nvSpPr>
+        <p:spPr>
+          <a:xfrm>
+            <a:off x="4507992" y="3273552"/>
+            <a:ext cx="3337560" cy="256032"/>
+          </a:xfrm>
+          <a:prstGeom prst="rect">
+            <a:avLst/>
+          </a:prstGeom>
+          <a:noFill/>
+        </p:spPr>
+        <p:txBody>
+          <a:bodyPr wrap="square">
+            <a:spAutoFit/>
+          </a:bodyPr>
+          <a:lstStyle/>
+          <a:p>
+            <a:pPr algn="l"/>
+            <a:r>
+              <a:rPr b="1" i="0" sz="1100">
+                <a:solidFill>
+                  <a:srgbClr val="A2A8B4"/>
+                </a:solidFill>
+                <a:latin typeface="Calibri"/>
+              </a:rPr>
+              <a:t>block time</a:t>
+            </a:r>
+          </a:p>
+        </p:txBody>
+      </p:sp>
+      <p:sp>
+        <p:nvSpPr>
+          <p:cNvPr id="13" name="TextBox 12"/>
+          <p:cNvSpPr txBox="1"/>
+          <p:nvPr/>
+        </p:nvSpPr>
+        <p:spPr>
+          <a:xfrm>
+            <a:off x="4507992" y="3566160"/>
+            <a:ext cx="3337560" cy="502920"/>
+          </a:xfrm>
+          <a:prstGeom prst="rect">
+            <a:avLst/>
+          </a:prstGeom>
+          <a:noFill/>
+        </p:spPr>
+        <p:txBody>
+          <a:bodyPr wrap="square">
+            <a:spAutoFit/>
+          </a:bodyPr>
+          <a:lstStyle/>
+          <a:p>
+            <a:pPr algn="l"/>
+            <a:r>
+              <a:rPr b="0" i="0" sz="1000">
+                <a:solidFill>
+                  <a:srgbClr val="6B7280"/>
+                </a:solidFill>
+                <a:latin typeface="Calibri"/>
+              </a:rPr>
+              <a:t>Pre-signing checks complete well inside a single block.</a:t>
+            </a:r>
+          </a:p>
+        </p:txBody>
+      </p:sp>
+      <p:sp>
+        <p:nvSpPr>
+          <p:cNvPr id="14" name="Rectangle 13"/>
+          <p:cNvSpPr/>
+          <p:nvPr/>
+        </p:nvSpPr>
+        <p:spPr>
+          <a:xfrm>
+            <a:off x="8046720" y="2743200"/>
+            <a:ext cx="3566160" cy="1417320"/>
+          </a:xfrm>
+          <a:prstGeom prst="rect">
+            <a:avLst/>
+          </a:prstGeom>
+          <a:solidFill>
+            <a:srgbClr val="14171F"/>
+          </a:solidFill>
+          <a:ln>
+            <a:noFill/>
+          </a:ln>
+        </p:spPr>
+        <p:style>
+          <a:lnRef idx="1">
+            <a:schemeClr val="accent1"/>
+          </a:lnRef>
+          <a:fillRef idx="3">
+            <a:schemeClr val="accent1"/>
+          </a:fillRef>
+          <a:effectRef idx="2">
+            <a:schemeClr val="accent1"/>
+          </a:effectRef>
+          <a:fontRef idx="minor">
+            <a:schemeClr val="lt1"/>
+          </a:fontRef>
+        </p:style>
+        <p:txBody>
+          <a:bodyPr rtlCol="0" anchor="ctr"/>
+          <a:lstStyle/>
+          <a:p>
+            <a:pPr algn="ctr"/>
+          </a:p>
+        </p:txBody>
+      </p:sp>
+      <p:sp>
+        <p:nvSpPr>
+          <p:cNvPr id="15" name="TextBox 14"/>
+          <p:cNvSpPr txBox="1"/>
+          <p:nvPr/>
+        </p:nvSpPr>
+        <p:spPr>
+          <a:xfrm>
+            <a:off x="8211312" y="2834640"/>
+            <a:ext cx="3337560" cy="457200"/>
+          </a:xfrm>
+          <a:prstGeom prst="rect">
+            <a:avLst/>
+          </a:prstGeom>
+          <a:noFill/>
+        </p:spPr>
+        <p:txBody>
+          <a:bodyPr wrap="square">
+            <a:spAutoFit/>
+          </a:bodyPr>
+          <a:lstStyle/>
+          <a:p>
+            <a:pPr algn="l"/>
+            <a:r>
+              <a:rPr b="1" i="0" sz="2200">
+                <a:solidFill>
+                  <a:srgbClr val="14F195"/>
+                </a:solidFill>
+                <a:latin typeface="Calibri"/>
+              </a:rPr>
+              <a:t>35M+</a:t>
+            </a:r>
+          </a:p>
+        </p:txBody>
+      </p:sp>
+      <p:sp>
+        <p:nvSpPr>
+          <p:cNvPr id="16" name="TextBox 15"/>
+          <p:cNvSpPr txBox="1"/>
+          <p:nvPr/>
+        </p:nvSpPr>
+        <p:spPr>
+          <a:xfrm>
+            <a:off x="8211312" y="3273552"/>
+            <a:ext cx="3337560" cy="256032"/>
+          </a:xfrm>
+          <a:prstGeom prst="rect">
+            <a:avLst/>
+          </a:prstGeom>
+          <a:noFill/>
+        </p:spPr>
+        <p:txBody>
+          <a:bodyPr wrap="square">
+            <a:spAutoFit/>
+          </a:bodyPr>
+          <a:lstStyle/>
+          <a:p>
+            <a:pPr algn="l"/>
+            <a:r>
+              <a:rPr b="1" i="0" sz="1100">
+                <a:solidFill>
+                  <a:srgbClr val="A2A8B4"/>
+                </a:solidFill>
+                <a:latin typeface="Calibri"/>
+              </a:rPr>
+              <a:t>Solana x402 txns</a:t>
+            </a:r>
+          </a:p>
+        </p:txBody>
+      </p:sp>
+      <p:sp>
+        <p:nvSpPr>
+          <p:cNvPr id="17" name="TextBox 16"/>
+          <p:cNvSpPr txBox="1"/>
+          <p:nvPr/>
+        </p:nvSpPr>
+        <p:spPr>
+          <a:xfrm>
+            <a:off x="8211312" y="3566160"/>
+            <a:ext cx="3337560" cy="502920"/>
+          </a:xfrm>
+          <a:prstGeom prst="rect">
+            <a:avLst/>
+          </a:prstGeom>
+          <a:noFill/>
+        </p:spPr>
+        <p:txBody>
+          <a:bodyPr wrap="square">
+            <a:spAutoFit/>
+          </a:bodyPr>
+          <a:lstStyle/>
+          <a:p>
+            <a:pPr algn="l"/>
+            <a:r>
+              <a:rPr b="0" i="0" sz="1000">
+                <a:solidFill>
+                  <a:srgbClr val="6B7280"/>
+                </a:solidFill>
+                <a:latin typeface="Calibri"/>
+              </a:rPr>
+              <a:t>The rail is already live — SAFE plugs into existing volume.</a:t>
+            </a:r>
+          </a:p>
+        </p:txBody>
+      </p:sp>
+      <p:sp>
+        <p:nvSpPr>
+          <p:cNvPr id="18" name="Rectangle 17"/>
+          <p:cNvSpPr/>
+          <p:nvPr/>
+        </p:nvSpPr>
+        <p:spPr>
+          <a:xfrm>
+            <a:off x="640080" y="4325112"/>
+            <a:ext cx="3566160" cy="1417320"/>
           </a:xfrm>
           <a:prstGeom prst="rect">
             <a:avLst/>
@@ -8992,49 +9507,119 @@
       </p:sp>
       <p:sp>
         <p:nvSpPr>
-          <p:cNvPr id="7" name="TextBox 6"/>
-          <p:cNvSpPr txBox="1"/>
-          <p:nvPr/>
-        </p:nvSpPr>
-        <p:spPr>
-          <a:xfrm>
-            <a:off x="731520" y="2953512"/>
-            <a:ext cx="1892808" cy="256032"/>
-          </a:xfrm>
-          <a:prstGeom prst="rect">
-            <a:avLst/>
-          </a:prstGeom>
-          <a:noFill/>
-        </p:spPr>
-        <p:txBody>
-          <a:bodyPr wrap="square">
-            <a:spAutoFit/>
-          </a:bodyPr>
-          <a:lstStyle/>
-          <a:p>
-            <a:pPr algn="l"/>
-            <a:r>
-              <a:rPr b="1" i="0" sz="1000">
-                <a:solidFill>
-                  <a:srgbClr val="14F195"/>
-                </a:solidFill>
-                <a:latin typeface="Calibri"/>
-              </a:rPr>
-              <a:t>private verifier agent</a:t>
-            </a:r>
-          </a:p>
-        </p:txBody>
-      </p:sp>
-      <p:sp>
-        <p:nvSpPr>
-          <p:cNvPr id="8" name="Rectangle 7"/>
+          <p:cNvPr id="19" name="TextBox 18"/>
+          <p:cNvSpPr txBox="1"/>
+          <p:nvPr/>
+        </p:nvSpPr>
+        <p:spPr>
+          <a:xfrm>
+            <a:off x="804672" y="4416552"/>
+            <a:ext cx="3337560" cy="457200"/>
+          </a:xfrm>
+          <a:prstGeom prst="rect">
+            <a:avLst/>
+          </a:prstGeom>
+          <a:noFill/>
+        </p:spPr>
+        <p:txBody>
+          <a:bodyPr wrap="square">
+            <a:spAutoFit/>
+          </a:bodyPr>
+          <a:lstStyle/>
+          <a:p>
+            <a:pPr algn="l"/>
+            <a:r>
+              <a:rPr b="1" i="0" sz="2200">
+                <a:solidFill>
+                  <a:srgbClr val="38BDF8"/>
+                </a:solidFill>
+                <a:latin typeface="Calibri"/>
+              </a:rPr>
+              <a:t>transferFixed</a:t>
+            </a:r>
+          </a:p>
+        </p:txBody>
+      </p:sp>
+      <p:sp>
+        <p:nvSpPr>
+          <p:cNvPr id="20" name="TextBox 19"/>
+          <p:cNvSpPr txBox="1"/>
+          <p:nvPr/>
+        </p:nvSpPr>
+        <p:spPr>
+          <a:xfrm>
+            <a:off x="804672" y="4855464"/>
+            <a:ext cx="3337560" cy="256032"/>
+          </a:xfrm>
+          <a:prstGeom prst="rect">
+            <a:avLst/>
+          </a:prstGeom>
+          <a:noFill/>
+        </p:spPr>
+        <p:txBody>
+          <a:bodyPr wrap="square">
+            <a:spAutoFit/>
+          </a:bodyPr>
+          <a:lstStyle/>
+          <a:p>
+            <a:pPr algn="l"/>
+            <a:r>
+              <a:rPr b="1" i="0" sz="1100">
+                <a:solidFill>
+                  <a:srgbClr val="A2A8B4"/>
+                </a:solidFill>
+                <a:latin typeface="Calibri"/>
+              </a:rPr>
+              <a:t>@solana/subscriptions</a:t>
+            </a:r>
+          </a:p>
+        </p:txBody>
+      </p:sp>
+      <p:sp>
+        <p:nvSpPr>
+          <p:cNvPr id="21" name="TextBox 20"/>
+          <p:cNvSpPr txBox="1"/>
+          <p:nvPr/>
+        </p:nvSpPr>
+        <p:spPr>
+          <a:xfrm>
+            <a:off x="804672" y="5148072"/>
+            <a:ext cx="3337560" cy="502920"/>
+          </a:xfrm>
+          <a:prstGeom prst="rect">
+            <a:avLst/>
+          </a:prstGeom>
+          <a:noFill/>
+        </p:spPr>
+        <p:txBody>
+          <a:bodyPr wrap="square">
+            <a:spAutoFit/>
+          </a:bodyPr>
+          <a:lstStyle/>
+          <a:p>
+            <a:pPr algn="l"/>
+            <a:r>
+              <a:rPr b="0" i="0" sz="1000">
+                <a:solidFill>
+                  <a:srgbClr val="6B7280"/>
+                </a:solidFill>
+                <a:latin typeface="Calibri"/>
+              </a:rPr>
+              <a:t>Native allowance primitive: agents spend from a capped pool, not a free wallet.</a:t>
+            </a:r>
+          </a:p>
+        </p:txBody>
+      </p:sp>
+      <p:sp>
+        <p:nvSpPr>
+          <p:cNvPr id="22" name="Rectangle 21"/>
           <p:cNvSpPr/>
           <p:nvPr/>
         </p:nvSpPr>
         <p:spPr>
           <a:xfrm>
-            <a:off x="2761488" y="2926080"/>
-            <a:ext cx="1906524" cy="256032"/>
+            <a:off x="4343400" y="4325112"/>
+            <a:ext cx="3566160" cy="1417320"/>
           </a:xfrm>
           <a:prstGeom prst="rect">
             <a:avLst/>
@@ -9070,49 +9655,119 @@
       </p:sp>
       <p:sp>
         <p:nvSpPr>
-          <p:cNvPr id="9" name="TextBox 8"/>
-          <p:cNvSpPr txBox="1"/>
-          <p:nvPr/>
-        </p:nvSpPr>
-        <p:spPr>
-          <a:xfrm>
-            <a:off x="2852928" y="2953512"/>
-            <a:ext cx="1815084" cy="256032"/>
-          </a:xfrm>
-          <a:prstGeom prst="rect">
-            <a:avLst/>
-          </a:prstGeom>
-          <a:noFill/>
-        </p:spPr>
-        <p:txBody>
-          <a:bodyPr wrap="square">
-            <a:spAutoFit/>
-          </a:bodyPr>
-          <a:lstStyle/>
-          <a:p>
-            <a:pPr algn="l"/>
-            <a:r>
-              <a:rPr b="1" i="0" sz="1000">
-                <a:solidFill>
-                  <a:srgbClr val="38BDF8"/>
-                </a:solidFill>
-                <a:latin typeface="Calibri"/>
-              </a:rPr>
-              <a:t>shared trust database</a:t>
-            </a:r>
-          </a:p>
-        </p:txBody>
-      </p:sp>
-      <p:sp>
-        <p:nvSpPr>
-          <p:cNvPr id="10" name="Rectangle 9"/>
+          <p:cNvPr id="23" name="TextBox 22"/>
+          <p:cNvSpPr txBox="1"/>
+          <p:nvPr/>
+        </p:nvSpPr>
+        <p:spPr>
+          <a:xfrm>
+            <a:off x="4507992" y="4416552"/>
+            <a:ext cx="3337560" cy="457200"/>
+          </a:xfrm>
+          <a:prstGeom prst="rect">
+            <a:avLst/>
+          </a:prstGeom>
+          <a:noFill/>
+        </p:spPr>
+        <p:txBody>
+          <a:bodyPr wrap="square">
+            <a:spAutoFit/>
+          </a:bodyPr>
+          <a:lstStyle/>
+          <a:p>
+            <a:pPr algn="l"/>
+            <a:r>
+              <a:rPr b="1" i="0" sz="2200">
+                <a:solidFill>
+                  <a:srgbClr val="F4F7FA"/>
+                </a:solidFill>
+                <a:latin typeface="Calibri"/>
+              </a:rPr>
+              <a:t>USDC (SPL)</a:t>
+            </a:r>
+          </a:p>
+        </p:txBody>
+      </p:sp>
+      <p:sp>
+        <p:nvSpPr>
+          <p:cNvPr id="24" name="TextBox 23"/>
+          <p:cNvSpPr txBox="1"/>
+          <p:nvPr/>
+        </p:nvSpPr>
+        <p:spPr>
+          <a:xfrm>
+            <a:off x="4507992" y="4855464"/>
+            <a:ext cx="3337560" cy="256032"/>
+          </a:xfrm>
+          <a:prstGeom prst="rect">
+            <a:avLst/>
+          </a:prstGeom>
+          <a:noFill/>
+        </p:spPr>
+        <p:txBody>
+          <a:bodyPr wrap="square">
+            <a:spAutoFit/>
+          </a:bodyPr>
+          <a:lstStyle/>
+          <a:p>
+            <a:pPr algn="l"/>
+            <a:r>
+              <a:rPr b="1" i="0" sz="1100">
+                <a:solidFill>
+                  <a:srgbClr val="A2A8B4"/>
+                </a:solidFill>
+                <a:latin typeface="Calibri"/>
+              </a:rPr>
+              <a:t>native stablecoin</a:t>
+            </a:r>
+          </a:p>
+        </p:txBody>
+      </p:sp>
+      <p:sp>
+        <p:nvSpPr>
+          <p:cNvPr id="25" name="TextBox 24"/>
+          <p:cNvSpPr txBox="1"/>
+          <p:nvPr/>
+        </p:nvSpPr>
+        <p:spPr>
+          <a:xfrm>
+            <a:off x="4507992" y="5148072"/>
+            <a:ext cx="3337560" cy="502920"/>
+          </a:xfrm>
+          <a:prstGeom prst="rect">
+            <a:avLst/>
+          </a:prstGeom>
+          <a:noFill/>
+        </p:spPr>
+        <p:txBody>
+          <a:bodyPr wrap="square">
+            <a:spAutoFit/>
+          </a:bodyPr>
+          <a:lstStyle/>
+          <a:p>
+            <a:pPr algn="l"/>
+            <a:r>
+              <a:rPr b="0" i="0" sz="1000">
+                <a:solidFill>
+                  <a:srgbClr val="6B7280"/>
+                </a:solidFill>
+                <a:latin typeface="Calibri"/>
+              </a:rPr>
+              <a:t>No wrapping. Agent payments settle in the stablecoin already on-chain.</a:t>
+            </a:r>
+          </a:p>
+        </p:txBody>
+      </p:sp>
+      <p:sp>
+        <p:nvSpPr>
+          <p:cNvPr id="26" name="Rectangle 25"/>
           <p:cNvSpPr/>
           <p:nvPr/>
         </p:nvSpPr>
         <p:spPr>
           <a:xfrm>
-            <a:off x="4805172" y="2926080"/>
-            <a:ext cx="1828800" cy="256032"/>
+            <a:off x="8046720" y="4325112"/>
+            <a:ext cx="3566160" cy="1417320"/>
           </a:xfrm>
           <a:prstGeom prst="rect">
             <a:avLst/>
@@ -9148,48 +9803,354 @@
       </p:sp>
       <p:sp>
         <p:nvSpPr>
-          <p:cNvPr id="11" name="TextBox 10"/>
-          <p:cNvSpPr txBox="1"/>
-          <p:nvPr/>
-        </p:nvSpPr>
-        <p:spPr>
-          <a:xfrm>
-            <a:off x="4896612" y="2953512"/>
-            <a:ext cx="1737360" cy="256032"/>
-          </a:xfrm>
-          <a:prstGeom prst="rect">
-            <a:avLst/>
-          </a:prstGeom>
-          <a:noFill/>
-        </p:spPr>
-        <p:txBody>
-          <a:bodyPr wrap="square">
-            <a:spAutoFit/>
-          </a:bodyPr>
-          <a:lstStyle/>
-          <a:p>
-            <a:pPr algn="l"/>
-            <a:r>
-              <a:rPr b="1" i="0" sz="1000">
+          <p:cNvPr id="27" name="TextBox 26"/>
+          <p:cNvSpPr txBox="1"/>
+          <p:nvPr/>
+        </p:nvSpPr>
+        <p:spPr>
+          <a:xfrm>
+            <a:off x="8211312" y="4416552"/>
+            <a:ext cx="3337560" cy="457200"/>
+          </a:xfrm>
+          <a:prstGeom prst="rect">
+            <a:avLst/>
+          </a:prstGeom>
+          <a:noFill/>
+        </p:spPr>
+        <p:txBody>
+          <a:bodyPr wrap="square">
+            <a:spAutoFit/>
+          </a:bodyPr>
+          <a:lstStyle/>
+          <a:p>
+            <a:pPr algn="l"/>
+            <a:r>
+              <a:rPr b="1" i="0" sz="2200">
                 <a:solidFill>
                   <a:srgbClr val="6B7280"/>
                 </a:solidFill>
                 <a:latin typeface="Calibri"/>
               </a:rPr>
-              <a:t>Solana proof anchors</a:t>
-            </a:r>
-          </a:p>
-        </p:txBody>
-      </p:sp>
-      <p:sp>
-        <p:nvSpPr>
-          <p:cNvPr id="12" name="Rectangle 11"/>
+              <a:t>Anchor programs</a:t>
+            </a:r>
+          </a:p>
+        </p:txBody>
+      </p:sp>
+      <p:sp>
+        <p:nvSpPr>
+          <p:cNvPr id="28" name="TextBox 27"/>
+          <p:cNvSpPr txBox="1"/>
+          <p:nvPr/>
+        </p:nvSpPr>
+        <p:spPr>
+          <a:xfrm>
+            <a:off x="8211312" y="4855464"/>
+            <a:ext cx="3337560" cy="256032"/>
+          </a:xfrm>
+          <a:prstGeom prst="rect">
+            <a:avLst/>
+          </a:prstGeom>
+          <a:noFill/>
+        </p:spPr>
+        <p:txBody>
+          <a:bodyPr wrap="square">
+            <a:spAutoFit/>
+          </a:bodyPr>
+          <a:lstStyle/>
+          <a:p>
+            <a:pPr algn="l"/>
+            <a:r>
+              <a:rPr b="1" i="0" sz="1100">
+                <a:solidFill>
+                  <a:srgbClr val="A2A8B4"/>
+                </a:solidFill>
+                <a:latin typeface="Calibri"/>
+              </a:rPr>
+              <a:t>on-chain policy</a:t>
+            </a:r>
+          </a:p>
+        </p:txBody>
+      </p:sp>
+      <p:sp>
+        <p:nvSpPr>
+          <p:cNvPr id="29" name="TextBox 28"/>
+          <p:cNvSpPr txBox="1"/>
+          <p:nvPr/>
+        </p:nvSpPr>
+        <p:spPr>
+          <a:xfrm>
+            <a:off x="8211312" y="5148072"/>
+            <a:ext cx="3337560" cy="502920"/>
+          </a:xfrm>
+          <a:prstGeom prst="rect">
+            <a:avLst/>
+          </a:prstGeom>
+          <a:noFill/>
+        </p:spPr>
+        <p:txBody>
+          <a:bodyPr wrap="square">
+            <a:spAutoFit/>
+          </a:bodyPr>
+          <a:lstStyle/>
+          <a:p>
+            <a:pPr algn="l"/>
+            <a:r>
+              <a:rPr b="0" i="0" sz="1000">
+                <a:solidFill>
+                  <a:srgbClr val="6B7280"/>
+                </a:solidFill>
+                <a:latin typeface="Calibri"/>
+              </a:rPr>
+              <a:t>Future: move firewall rules on-chain for trustless enforcement.</a:t>
+            </a:r>
+          </a:p>
+        </p:txBody>
+      </p:sp>
+      <p:sp>
+        <p:nvSpPr>
+          <p:cNvPr id="30" name="TextBox 29"/>
+          <p:cNvSpPr txBox="1"/>
+          <p:nvPr/>
+        </p:nvSpPr>
+        <p:spPr>
+          <a:xfrm>
+            <a:off x="640080" y="6309360"/>
+            <a:ext cx="8229600" cy="320040"/>
+          </a:xfrm>
+          <a:prstGeom prst="rect">
+            <a:avLst/>
+          </a:prstGeom>
+          <a:noFill/>
+        </p:spPr>
+        <p:txBody>
+          <a:bodyPr wrap="square">
+            <a:spAutoFit/>
+          </a:bodyPr>
+          <a:lstStyle/>
+          <a:p>
+            <a:pPr algn="l"/>
+            <a:r>
+              <a:rPr b="0" i="0" sz="1000">
+                <a:solidFill>
+                  <a:srgbClr val="6B7280"/>
+                </a:solidFill>
+                <a:latin typeface="Calibri"/>
+              </a:rPr>
+              <a:t>Solana allowances are the only chain-native cap model that fits an agent firewall.</a:t>
+            </a:r>
+          </a:p>
+        </p:txBody>
+      </p:sp>
+      <p:sp>
+        <p:nvSpPr>
+          <p:cNvPr id="31" name="TextBox 30"/>
+          <p:cNvSpPr txBox="1"/>
+          <p:nvPr/>
+        </p:nvSpPr>
+        <p:spPr>
+          <a:xfrm>
+            <a:off x="9144000" y="6309360"/>
+            <a:ext cx="2743200" cy="320040"/>
+          </a:xfrm>
+          <a:prstGeom prst="rect">
+            <a:avLst/>
+          </a:prstGeom>
+          <a:noFill/>
+        </p:spPr>
+        <p:txBody>
+          <a:bodyPr wrap="square">
+            <a:spAutoFit/>
+          </a:bodyPr>
+          <a:lstStyle/>
+          <a:p>
+            <a:pPr algn="r"/>
+            <a:r>
+              <a:rPr b="0" i="0" sz="1000">
+                <a:solidFill>
+                  <a:srgbClr val="6B7280"/>
+                </a:solidFill>
+                <a:latin typeface="Calibri"/>
+              </a:rPr>
+              <a:t>07 / 08</a:t>
+            </a:r>
+          </a:p>
+        </p:txBody>
+      </p:sp>
+    </p:spTree>
+  </p:cSld>
+  <p:clrMapOvr>
+    <a:masterClrMapping/>
+  </p:clrMapOvr>
+</p:sld>
+</file>
+
+<file path=ppt/slides/slide8.xml><?xml version="1.0" encoding="utf-8"?>
+<p:sld xmlns:a="http://schemas.openxmlformats.org/drawingml/2006/main" xmlns:p="http://schemas.openxmlformats.org/presentationml/2006/main" xmlns:r="http://schemas.openxmlformats.org/officeDocument/2006/relationships">
+  <p:cSld>
+    <p:bg>
+      <p:bgPr>
+        <a:solidFill>
+          <a:srgbClr val="0A0C11"/>
+        </a:solidFill>
+        <a:effectLst/>
+      </p:bgPr>
+    </p:bg>
+    <p:spTree>
+      <p:nvGrpSpPr>
+        <p:cNvPr id="1" name=""/>
+        <p:cNvGrpSpPr/>
+        <p:nvPr/>
+      </p:nvGrpSpPr>
+      <p:grpSpPr/>
+      <p:sp>
+        <p:nvSpPr>
+          <p:cNvPr id="2" name="TextBox 1"/>
+          <p:cNvSpPr txBox="1"/>
+          <p:nvPr/>
+        </p:nvSpPr>
+        <p:spPr>
+          <a:xfrm>
+            <a:off x="640080" y="320040"/>
+            <a:ext cx="6400800" cy="365760"/>
+          </a:xfrm>
+          <a:prstGeom prst="rect">
+            <a:avLst/>
+          </a:prstGeom>
+          <a:noFill/>
+        </p:spPr>
+        <p:txBody>
+          <a:bodyPr wrap="square">
+            <a:spAutoFit/>
+          </a:bodyPr>
+          <a:lstStyle/>
+          <a:p>
+            <a:pPr algn="l"/>
+            <a:r>
+              <a:rPr b="1" i="0" sz="1100">
+                <a:solidFill>
+                  <a:srgbClr val="14F195"/>
+                </a:solidFill>
+                <a:latin typeface="Courier New"/>
+              </a:rPr>
+              <a:t>// Grand Vision</a:t>
+            </a:r>
+          </a:p>
+        </p:txBody>
+      </p:sp>
+      <p:sp>
+        <p:nvSpPr>
+          <p:cNvPr id="3" name="TextBox 2"/>
+          <p:cNvSpPr txBox="1"/>
+          <p:nvPr/>
+        </p:nvSpPr>
+        <p:spPr>
+          <a:xfrm>
+            <a:off x="6858000" y="320040"/>
+            <a:ext cx="5029200" cy="365760"/>
+          </a:xfrm>
+          <a:prstGeom prst="rect">
+            <a:avLst/>
+          </a:prstGeom>
+          <a:noFill/>
+        </p:spPr>
+        <p:txBody>
+          <a:bodyPr wrap="square">
+            <a:spAutoFit/>
+          </a:bodyPr>
+          <a:lstStyle/>
+          <a:p>
+            <a:pPr algn="r"/>
+            <a:r>
+              <a:rPr b="0" i="0" sz="1100">
+                <a:solidFill>
+                  <a:srgbClr val="6B7280"/>
+                </a:solidFill>
+                <a:latin typeface="Calibri"/>
+              </a:rPr>
+              <a:t>Private-first, shared-by-proof</a:t>
+            </a:r>
+          </a:p>
+        </p:txBody>
+      </p:sp>
+      <p:sp>
+        <p:nvSpPr>
+          <p:cNvPr id="4" name="TextBox 3"/>
+          <p:cNvSpPr txBox="1"/>
+          <p:nvPr/>
+        </p:nvSpPr>
+        <p:spPr>
+          <a:xfrm>
+            <a:off x="640080" y="1005840"/>
+            <a:ext cx="5943600" cy="822960"/>
+          </a:xfrm>
+          <a:prstGeom prst="rect">
+            <a:avLst/>
+          </a:prstGeom>
+          <a:noFill/>
+        </p:spPr>
+        <p:txBody>
+          <a:bodyPr wrap="square">
+            <a:spAutoFit/>
+          </a:bodyPr>
+          <a:lstStyle/>
+          <a:p>
+            <a:pPr algn="l"/>
+            <a:r>
+              <a:rPr b="1" i="0" sz="3000">
+                <a:solidFill>
+                  <a:srgbClr val="F4F7FA"/>
+                </a:solidFill>
+                <a:latin typeface="Calibri"/>
+              </a:rPr>
+              <a:t>From payment firewall to shared trust layer.</a:t>
+            </a:r>
+          </a:p>
+        </p:txBody>
+      </p:sp>
+      <p:sp>
+        <p:nvSpPr>
+          <p:cNvPr id="5" name="TextBox 4"/>
+          <p:cNvSpPr txBox="1"/>
+          <p:nvPr/>
+        </p:nvSpPr>
+        <p:spPr>
+          <a:xfrm>
+            <a:off x="640080" y="1920240"/>
+            <a:ext cx="5669280" cy="822960"/>
+          </a:xfrm>
+          <a:prstGeom prst="rect">
+            <a:avLst/>
+          </a:prstGeom>
+          <a:noFill/>
+        </p:spPr>
+        <p:txBody>
+          <a:bodyPr wrap="square">
+            <a:spAutoFit/>
+          </a:bodyPr>
+          <a:lstStyle/>
+          <a:p>
+            <a:pPr algn="l"/>
+            <a:r>
+              <a:rPr b="0" i="0" sz="1400">
+                <a:solidFill>
+                  <a:srgbClr val="A2A8B4"/>
+                </a:solidFill>
+                <a:latin typeface="Calibri"/>
+              </a:rPr>
+              <a:t>SAFE starts local. Then unknown payments can be verified by private agents, turned into signed evidence, and reused as sanitized trust signals.</a:t>
+            </a:r>
+          </a:p>
+        </p:txBody>
+      </p:sp>
+      <p:sp>
+        <p:nvSpPr>
+          <p:cNvPr id="6" name="Rectangle 5"/>
           <p:cNvSpPr/>
           <p:nvPr/>
         </p:nvSpPr>
         <p:spPr>
           <a:xfrm>
-            <a:off x="640080" y="3310128"/>
+            <a:off x="640080" y="2926080"/>
             <a:ext cx="1984248" cy="256032"/>
           </a:xfrm>
           <a:prstGeom prst="rect">
@@ -9226,13 +10187,13 @@
       </p:sp>
       <p:sp>
         <p:nvSpPr>
-          <p:cNvPr id="13" name="TextBox 12"/>
-          <p:cNvSpPr txBox="1"/>
-          <p:nvPr/>
-        </p:nvSpPr>
-        <p:spPr>
-          <a:xfrm>
-            <a:off x="731520" y="3337560"/>
+          <p:cNvPr id="7" name="TextBox 6"/>
+          <p:cNvSpPr txBox="1"/>
+          <p:nvPr/>
+        </p:nvSpPr>
+        <p:spPr>
+          <a:xfrm>
+            <a:off x="731520" y="2953512"/>
             <a:ext cx="1892808" cy="256032"/>
           </a:xfrm>
           <a:prstGeom prst="rect">
@@ -9250,25 +10211,25 @@
             <a:r>
               <a:rPr b="1" i="0" sz="1000">
                 <a:solidFill>
-                  <a:srgbClr val="6B7280"/>
-                </a:solidFill>
-                <a:latin typeface="Calibri"/>
-              </a:rPr>
-              <a:t>Filecoin/IPFS evidence</a:t>
-            </a:r>
-          </a:p>
-        </p:txBody>
-      </p:sp>
-      <p:sp>
-        <p:nvSpPr>
-          <p:cNvPr id="14" name="Rectangle 13"/>
+                  <a:srgbClr val="14F195"/>
+                </a:solidFill>
+                <a:latin typeface="Calibri"/>
+              </a:rPr>
+              <a:t>private verifier agent</a:t>
+            </a:r>
+          </a:p>
+        </p:txBody>
+      </p:sp>
+      <p:sp>
+        <p:nvSpPr>
+          <p:cNvPr id="8" name="Rectangle 7"/>
           <p:cNvSpPr/>
           <p:nvPr/>
         </p:nvSpPr>
         <p:spPr>
           <a:xfrm>
-            <a:off x="2761488" y="3310128"/>
-            <a:ext cx="2217420" cy="256032"/>
+            <a:off x="2761488" y="2926080"/>
+            <a:ext cx="1906524" cy="256032"/>
           </a:xfrm>
           <a:prstGeom prst="rect">
             <a:avLst/>
@@ -9304,14 +10265,14 @@
       </p:sp>
       <p:sp>
         <p:nvSpPr>
-          <p:cNvPr id="15" name="TextBox 14"/>
-          <p:cNvSpPr txBox="1"/>
-          <p:nvPr/>
-        </p:nvSpPr>
-        <p:spPr>
-          <a:xfrm>
-            <a:off x="2852928" y="3337560"/>
-            <a:ext cx="2125980" cy="256032"/>
+          <p:cNvPr id="9" name="TextBox 8"/>
+          <p:cNvSpPr txBox="1"/>
+          <p:nvPr/>
+        </p:nvSpPr>
+        <p:spPr>
+          <a:xfrm>
+            <a:off x="2852928" y="2953512"/>
+            <a:ext cx="1815084" cy="256032"/>
           </a:xfrm>
           <a:prstGeom prst="rect">
             <a:avLst/>
@@ -9328,25 +10289,25 @@
             <a:r>
               <a:rPr b="1" i="0" sz="1000">
                 <a:solidFill>
-                  <a:srgbClr val="6B7280"/>
-                </a:solidFill>
-                <a:latin typeface="Calibri"/>
-              </a:rPr>
-              <a:t>0G later for AI-native DA</a:t>
-            </a:r>
-          </a:p>
-        </p:txBody>
-      </p:sp>
-      <p:sp>
-        <p:nvSpPr>
-          <p:cNvPr id="16" name="Rectangle 15"/>
+                  <a:srgbClr val="38BDF8"/>
+                </a:solidFill>
+                <a:latin typeface="Calibri"/>
+              </a:rPr>
+              <a:t>shared trust database</a:t>
+            </a:r>
+          </a:p>
+        </p:txBody>
+      </p:sp>
+      <p:sp>
+        <p:nvSpPr>
+          <p:cNvPr id="10" name="Rectangle 9"/>
           <p:cNvSpPr/>
           <p:nvPr/>
         </p:nvSpPr>
         <p:spPr>
           <a:xfrm>
-            <a:off x="6583680" y="1005840"/>
-            <a:ext cx="5303520" cy="5029200"/>
+            <a:off x="4805172" y="2926080"/>
+            <a:ext cx="1828800" cy="256032"/>
           </a:xfrm>
           <a:prstGeom prst="rect">
             <a:avLst/>
@@ -9382,6 +10343,240 @@
       </p:sp>
       <p:sp>
         <p:nvSpPr>
+          <p:cNvPr id="11" name="TextBox 10"/>
+          <p:cNvSpPr txBox="1"/>
+          <p:nvPr/>
+        </p:nvSpPr>
+        <p:spPr>
+          <a:xfrm>
+            <a:off x="4896612" y="2953512"/>
+            <a:ext cx="1737360" cy="256032"/>
+          </a:xfrm>
+          <a:prstGeom prst="rect">
+            <a:avLst/>
+          </a:prstGeom>
+          <a:noFill/>
+        </p:spPr>
+        <p:txBody>
+          <a:bodyPr wrap="square">
+            <a:spAutoFit/>
+          </a:bodyPr>
+          <a:lstStyle/>
+          <a:p>
+            <a:pPr algn="l"/>
+            <a:r>
+              <a:rPr b="1" i="0" sz="1000">
+                <a:solidFill>
+                  <a:srgbClr val="6B7280"/>
+                </a:solidFill>
+                <a:latin typeface="Calibri"/>
+              </a:rPr>
+              <a:t>Solana proof anchors</a:t>
+            </a:r>
+          </a:p>
+        </p:txBody>
+      </p:sp>
+      <p:sp>
+        <p:nvSpPr>
+          <p:cNvPr id="12" name="Rectangle 11"/>
+          <p:cNvSpPr/>
+          <p:nvPr/>
+        </p:nvSpPr>
+        <p:spPr>
+          <a:xfrm>
+            <a:off x="640080" y="3310128"/>
+            <a:ext cx="1984248" cy="256032"/>
+          </a:xfrm>
+          <a:prstGeom prst="rect">
+            <a:avLst/>
+          </a:prstGeom>
+          <a:solidFill>
+            <a:srgbClr val="181C25"/>
+          </a:solidFill>
+          <a:ln>
+            <a:noFill/>
+          </a:ln>
+        </p:spPr>
+        <p:style>
+          <a:lnRef idx="1">
+            <a:schemeClr val="accent1"/>
+          </a:lnRef>
+          <a:fillRef idx="3">
+            <a:schemeClr val="accent1"/>
+          </a:fillRef>
+          <a:effectRef idx="2">
+            <a:schemeClr val="accent1"/>
+          </a:effectRef>
+          <a:fontRef idx="minor">
+            <a:schemeClr val="lt1"/>
+          </a:fontRef>
+        </p:style>
+        <p:txBody>
+          <a:bodyPr rtlCol="0" anchor="ctr"/>
+          <a:lstStyle/>
+          <a:p>
+            <a:pPr algn="ctr"/>
+          </a:p>
+        </p:txBody>
+      </p:sp>
+      <p:sp>
+        <p:nvSpPr>
+          <p:cNvPr id="13" name="TextBox 12"/>
+          <p:cNvSpPr txBox="1"/>
+          <p:nvPr/>
+        </p:nvSpPr>
+        <p:spPr>
+          <a:xfrm>
+            <a:off x="731520" y="3337560"/>
+            <a:ext cx="1892808" cy="256032"/>
+          </a:xfrm>
+          <a:prstGeom prst="rect">
+            <a:avLst/>
+          </a:prstGeom>
+          <a:noFill/>
+        </p:spPr>
+        <p:txBody>
+          <a:bodyPr wrap="square">
+            <a:spAutoFit/>
+          </a:bodyPr>
+          <a:lstStyle/>
+          <a:p>
+            <a:pPr algn="l"/>
+            <a:r>
+              <a:rPr b="1" i="0" sz="1000">
+                <a:solidFill>
+                  <a:srgbClr val="6B7280"/>
+                </a:solidFill>
+                <a:latin typeface="Calibri"/>
+              </a:rPr>
+              <a:t>Filecoin/IPFS evidence</a:t>
+            </a:r>
+          </a:p>
+        </p:txBody>
+      </p:sp>
+      <p:sp>
+        <p:nvSpPr>
+          <p:cNvPr id="14" name="Rectangle 13"/>
+          <p:cNvSpPr/>
+          <p:nvPr/>
+        </p:nvSpPr>
+        <p:spPr>
+          <a:xfrm>
+            <a:off x="2761488" y="3310128"/>
+            <a:ext cx="2217420" cy="256032"/>
+          </a:xfrm>
+          <a:prstGeom prst="rect">
+            <a:avLst/>
+          </a:prstGeom>
+          <a:solidFill>
+            <a:srgbClr val="181C25"/>
+          </a:solidFill>
+          <a:ln>
+            <a:noFill/>
+          </a:ln>
+        </p:spPr>
+        <p:style>
+          <a:lnRef idx="1">
+            <a:schemeClr val="accent1"/>
+          </a:lnRef>
+          <a:fillRef idx="3">
+            <a:schemeClr val="accent1"/>
+          </a:fillRef>
+          <a:effectRef idx="2">
+            <a:schemeClr val="accent1"/>
+          </a:effectRef>
+          <a:fontRef idx="minor">
+            <a:schemeClr val="lt1"/>
+          </a:fontRef>
+        </p:style>
+        <p:txBody>
+          <a:bodyPr rtlCol="0" anchor="ctr"/>
+          <a:lstStyle/>
+          <a:p>
+            <a:pPr algn="ctr"/>
+          </a:p>
+        </p:txBody>
+      </p:sp>
+      <p:sp>
+        <p:nvSpPr>
+          <p:cNvPr id="15" name="TextBox 14"/>
+          <p:cNvSpPr txBox="1"/>
+          <p:nvPr/>
+        </p:nvSpPr>
+        <p:spPr>
+          <a:xfrm>
+            <a:off x="2852928" y="3337560"/>
+            <a:ext cx="2125980" cy="256032"/>
+          </a:xfrm>
+          <a:prstGeom prst="rect">
+            <a:avLst/>
+          </a:prstGeom>
+          <a:noFill/>
+        </p:spPr>
+        <p:txBody>
+          <a:bodyPr wrap="square">
+            <a:spAutoFit/>
+          </a:bodyPr>
+          <a:lstStyle/>
+          <a:p>
+            <a:pPr algn="l"/>
+            <a:r>
+              <a:rPr b="1" i="0" sz="1000">
+                <a:solidFill>
+                  <a:srgbClr val="6B7280"/>
+                </a:solidFill>
+                <a:latin typeface="Calibri"/>
+              </a:rPr>
+              <a:t>0G later for AI-native DA</a:t>
+            </a:r>
+          </a:p>
+        </p:txBody>
+      </p:sp>
+      <p:sp>
+        <p:nvSpPr>
+          <p:cNvPr id="16" name="Rectangle 15"/>
+          <p:cNvSpPr/>
+          <p:nvPr/>
+        </p:nvSpPr>
+        <p:spPr>
+          <a:xfrm>
+            <a:off x="6583680" y="1005840"/>
+            <a:ext cx="5303520" cy="5029200"/>
+          </a:xfrm>
+          <a:prstGeom prst="rect">
+            <a:avLst/>
+          </a:prstGeom>
+          <a:solidFill>
+            <a:srgbClr val="181C25"/>
+          </a:solidFill>
+          <a:ln>
+            <a:noFill/>
+          </a:ln>
+        </p:spPr>
+        <p:style>
+          <a:lnRef idx="1">
+            <a:schemeClr val="accent1"/>
+          </a:lnRef>
+          <a:fillRef idx="3">
+            <a:schemeClr val="accent1"/>
+          </a:fillRef>
+          <a:effectRef idx="2">
+            <a:schemeClr val="accent1"/>
+          </a:effectRef>
+          <a:fontRef idx="minor">
+            <a:schemeClr val="lt1"/>
+          </a:fontRef>
+        </p:style>
+        <p:txBody>
+          <a:bodyPr rtlCol="0" anchor="ctr"/>
+          <a:lstStyle/>
+          <a:p>
+            <a:pPr algn="ctr"/>
+          </a:p>
+        </p:txBody>
+      </p:sp>
+      <p:sp>
+        <p:nvSpPr>
           <p:cNvPr id="17" name="TextBox 16"/>
           <p:cNvSpPr txBox="1"/>
           <p:nvPr/>
@@ -9725,7 +10920,7 @@
                 </a:solidFill>
                 <a:latin typeface="Calibri"/>
               </a:rPr>
-              <a:t>07 / 07</a:t>
+              <a:t>08 / 08</a:t>
             </a:r>
           </a:p>
         </p:txBody>

</xml_diff>